<commit_message>
Make expedited therapy intake the first product
Rewrites README to position Osanwe as an expedited, clinician-reviewed therapy-intake product (pre-production), including workflow, boundaries, safety, and production-readiness criteria. Adds ADR-0004 recording the decision to prioritize expedited therapy intake and defer longitudinal ML. Updates docs/decisions/README.md to reference ADR-0004. Regenerates pitch deck inspection and rendered slide/layout artifacts under docs/pitch and tmp/round-2-pitch. Co-authored-by: Copilot <223556219+Copilot@users.noreply.github.com>
</commit_message>
<xml_diff>
--- a/docs/pitch/round-2/osanwe-wayfinder-round-2.pptx
+++ b/docs/pitch/round-2/osanwe-wayfinder-round-2.pptx
@@ -2,17 +2,17 @@
 <file path=ppt/presentation.xml><?xml version="1.0" encoding="utf-8"?>
 <p:presentation xmlns:p="http://schemas.openxmlformats.org/presentationml/2006/main">
   <p:sldMasterIdLst>
-    <p:sldMasterId xmlns:r="http://schemas.openxmlformats.org/officeDocument/2006/relationships" id="2147483648" r:id="Rd87b84a1216746fd"/>
+    <p:sldMasterId xmlns:r="http://schemas.openxmlformats.org/officeDocument/2006/relationships" id="2147483648" r:id="Ra4ca081cb8104af3"/>
   </p:sldMasterIdLst>
   <p:notesMasterIdLst>
-    <p:notesMasterId xmlns:r="http://schemas.openxmlformats.org/officeDocument/2006/relationships" r:id="R15dabd808cfb440e"/>
+    <p:notesMasterId xmlns:r="http://schemas.openxmlformats.org/officeDocument/2006/relationships" r:id="R9e96a8ed75884220"/>
   </p:notesMasterIdLst>
   <p:sldIdLst>
-    <p:sldId xmlns:r="http://schemas.openxmlformats.org/officeDocument/2006/relationships" id="256" r:id="Rc013003e389d4c38"/>
-    <p:sldId xmlns:r="http://schemas.openxmlformats.org/officeDocument/2006/relationships" id="257" r:id="R8fe97a23a7ff4219"/>
-    <p:sldId xmlns:r="http://schemas.openxmlformats.org/officeDocument/2006/relationships" id="258" r:id="R9340020daee549a4"/>
-    <p:sldId xmlns:r="http://schemas.openxmlformats.org/officeDocument/2006/relationships" id="259" r:id="Rc2f84a8f8a19479f"/>
-    <p:sldId xmlns:r="http://schemas.openxmlformats.org/officeDocument/2006/relationships" id="260" r:id="Rda076f68005f4988"/>
+    <p:sldId xmlns:r="http://schemas.openxmlformats.org/officeDocument/2006/relationships" id="256" r:id="R6b68391cf4de4cbe"/>
+    <p:sldId xmlns:r="http://schemas.openxmlformats.org/officeDocument/2006/relationships" id="257" r:id="R3092cf404cd54637"/>
+    <p:sldId xmlns:r="http://schemas.openxmlformats.org/officeDocument/2006/relationships" id="258" r:id="R8bd4203858ae433b"/>
+    <p:sldId xmlns:r="http://schemas.openxmlformats.org/officeDocument/2006/relationships" id="259" r:id="Rcf2065b7336a4045"/>
+    <p:sldId xmlns:r="http://schemas.openxmlformats.org/officeDocument/2006/relationships" id="260" r:id="R5a0d13abfef04a31"/>
   </p:sldIdLst>
   <p:sldSz cx="12192000" cy="6858000"/>
   <p:notesSz cx="6858000" cy="9144000"/>
@@ -871,7 +871,7 @@
           <a:lstStyle xmlns:a="http://schemas.openxmlformats.org/drawingml/2006/main"/>
           <a:p xmlns:a="http://schemas.openxmlformats.org/drawingml/2006/main">
             <a:r>
-              <a:t>This is not a diagnosis, and the current prototype uses synthetic data.</a:t>
+              <a:t>This is not a diagnosis, and the prototype uses synthetic data.</a:t>
             </a:r>
           </a:p>
           <a:p xmlns:a="http://schemas.openxmlformats.org/drawingml/2006/main">
@@ -989,7 +989,7 @@
   </p:cSld>
   <p:clrMap bg1="lt1" tx1="dk1" bg2="lt2" tx2="dk2" accent1="accent1" accent2="accent2" accent3="accent3" accent4="accent4" accent5="accent5" accent6="accent6" hlink="hlink" folHlink="folHlink"/>
   <p:sldLayoutIdLst>
-    <p:sldLayoutId xmlns:r="http://schemas.openxmlformats.org/officeDocument/2006/relationships" id="2147483649" r:id="R2a85410ad16b47e0"/>
+    <p:sldLayoutId xmlns:r="http://schemas.openxmlformats.org/officeDocument/2006/relationships" id="2147483649" r:id="R9b1057850d7a456a"/>
   </p:sldLayoutIdLst>
   <p:txStyles>
     <p:titleStyle>
@@ -1540,7 +1540,7 @@
           <p:cNvPr id="13" name="brand-1">
             <a:extLst xmlns:a="http://schemas.openxmlformats.org/drawingml/2006/main">
               <a:ext uri="{FF2B5EF4-FFF2-40B4-BE49-F238E27FC236}">
-                <a16:creationId xmlns:a16="http://schemas.microsoft.com/office/drawing/2014/main" id="{6654EEB5-6BE6-4029-83EC-908BC8E8F1B4}"/>
+                <a16:creationId xmlns:a16="http://schemas.microsoft.com/office/drawing/2014/main" id="{D662621B-7494-4E0B-998D-AF8DB4B90302}"/>
               </a:ext>
             </a:extLst>
           </p:cNvPr>
@@ -1598,7 +1598,7 @@
           <p:cNvPr id="2" name="round-1">
             <a:extLst xmlns:a="http://schemas.openxmlformats.org/drawingml/2006/main">
               <a:ext uri="{FF2B5EF4-FFF2-40B4-BE49-F238E27FC236}">
-                <a16:creationId xmlns:a16="http://schemas.microsoft.com/office/drawing/2014/main" id="{B7ED372D-C94B-4455-B799-63D0D16A6F43}"/>
+                <a16:creationId xmlns:a16="http://schemas.microsoft.com/office/drawing/2014/main" id="{7619B49E-5D77-437A-8597-2E9CAD6278DE}"/>
               </a:ext>
             </a:extLst>
           </p:cNvPr>
@@ -1656,7 +1656,7 @@
           <p:cNvPr id="3" name="top-rule-1">
             <a:extLst xmlns:a="http://schemas.openxmlformats.org/drawingml/2006/main">
               <a:ext uri="{FF2B5EF4-FFF2-40B4-BE49-F238E27FC236}">
-                <a16:creationId xmlns:a16="http://schemas.microsoft.com/office/drawing/2014/main" id="{346DA23A-3BF9-45B6-9627-53672B3600B3}"/>
+                <a16:creationId xmlns:a16="http://schemas.microsoft.com/office/drawing/2014/main" id="{8DE093CC-0A74-436C-A273-E17135ADC863}"/>
               </a:ext>
             </a:extLst>
           </p:cNvPr>
@@ -1689,7 +1689,7 @@
           <p:cNvPr id="4" name="left-grid-1">
             <a:extLst xmlns:a="http://schemas.openxmlformats.org/drawingml/2006/main">
               <a:ext uri="{FF2B5EF4-FFF2-40B4-BE49-F238E27FC236}">
-                <a16:creationId xmlns:a16="http://schemas.microsoft.com/office/drawing/2014/main" id="{7E9F662B-AA95-4C0A-8118-2699A5017963}"/>
+                <a16:creationId xmlns:a16="http://schemas.microsoft.com/office/drawing/2014/main" id="{544287BB-3ED8-4C89-AE78-A0BB0C8311A7}"/>
               </a:ext>
             </a:extLst>
           </p:cNvPr>
@@ -1722,7 +1722,7 @@
           <p:cNvPr id="5" name="center-grid-1">
             <a:extLst xmlns:a="http://schemas.openxmlformats.org/drawingml/2006/main">
               <a:ext uri="{FF2B5EF4-FFF2-40B4-BE49-F238E27FC236}">
-                <a16:creationId xmlns:a16="http://schemas.microsoft.com/office/drawing/2014/main" id="{067DE5AB-7DCE-4D7D-BC20-3B1A47F5458D}"/>
+                <a16:creationId xmlns:a16="http://schemas.microsoft.com/office/drawing/2014/main" id="{DBFA17E5-F47B-4C9B-A1AF-262A8A537BC7}"/>
               </a:ext>
             </a:extLst>
           </p:cNvPr>
@@ -1755,7 +1755,7 @@
           <p:cNvPr id="6" name="right-grid-1">
             <a:extLst xmlns:a="http://schemas.openxmlformats.org/drawingml/2006/main">
               <a:ext uri="{FF2B5EF4-FFF2-40B4-BE49-F238E27FC236}">
-                <a16:creationId xmlns:a16="http://schemas.microsoft.com/office/drawing/2014/main" id="{990DA7D4-7D40-4EF3-8F42-E92B08B5B87D}"/>
+                <a16:creationId xmlns:a16="http://schemas.microsoft.com/office/drawing/2014/main" id="{E1B26BCF-14FC-4C38-9CC2-5A9763FE51CF}"/>
               </a:ext>
             </a:extLst>
           </p:cNvPr>
@@ -1788,7 +1788,7 @@
           <p:cNvPr id="7" name="bottom-rule-1">
             <a:extLst xmlns:a="http://schemas.openxmlformats.org/drawingml/2006/main">
               <a:ext uri="{FF2B5EF4-FFF2-40B4-BE49-F238E27FC236}">
-                <a16:creationId xmlns:a16="http://schemas.microsoft.com/office/drawing/2014/main" id="{38A23C69-E653-4BE2-9E61-D0E037636C88}"/>
+                <a16:creationId xmlns:a16="http://schemas.microsoft.com/office/drawing/2014/main" id="{747F115C-C625-4580-A8B2-199AC635CAE8}"/>
               </a:ext>
             </a:extLst>
           </p:cNvPr>
@@ -1821,7 +1821,7 @@
           <p:cNvPr id="8" name="page-1">
             <a:extLst xmlns:a="http://schemas.openxmlformats.org/drawingml/2006/main">
               <a:ext uri="{FF2B5EF4-FFF2-40B4-BE49-F238E27FC236}">
-                <a16:creationId xmlns:a16="http://schemas.microsoft.com/office/drawing/2014/main" id="{A24652C4-AF80-49BA-B44A-22663A63413B}"/>
+                <a16:creationId xmlns:a16="http://schemas.microsoft.com/office/drawing/2014/main" id="{F0553739-008D-440E-876A-717138BA364E}"/>
               </a:ext>
             </a:extLst>
           </p:cNvPr>
@@ -1879,7 +1879,7 @@
           <p:cNvPr id="9" name="thesis-kicker">
             <a:extLst xmlns:a="http://schemas.openxmlformats.org/drawingml/2006/main">
               <a:ext uri="{FF2B5EF4-FFF2-40B4-BE49-F238E27FC236}">
-                <a16:creationId xmlns:a16="http://schemas.microsoft.com/office/drawing/2014/main" id="{2CBAFFF8-63E2-40BA-9E98-E288856CA7F5}"/>
+                <a16:creationId xmlns:a16="http://schemas.microsoft.com/office/drawing/2014/main" id="{96EE5D73-853E-4BBD-98DA-D48943899075}"/>
               </a:ext>
             </a:extLst>
           </p:cNvPr>
@@ -1937,7 +1937,7 @@
           <p:cNvPr id="10" name="thesis-title">
             <a:extLst xmlns:a="http://schemas.openxmlformats.org/drawingml/2006/main">
               <a:ext uri="{FF2B5EF4-FFF2-40B4-BE49-F238E27FC236}">
-                <a16:creationId xmlns:a16="http://schemas.microsoft.com/office/drawing/2014/main" id="{BC66F950-26CF-49D1-910E-BDA5025E8171}"/>
+                <a16:creationId xmlns:a16="http://schemas.microsoft.com/office/drawing/2014/main" id="{964C59DC-022F-4BA5-8802-455BDD4B1298}"/>
               </a:ext>
             </a:extLst>
           </p:cNvPr>
@@ -2018,7 +2018,7 @@
           <p:cNvPr id="11" name="thesis-subtitle">
             <a:extLst xmlns:a="http://schemas.openxmlformats.org/drawingml/2006/main">
               <a:ext uri="{FF2B5EF4-FFF2-40B4-BE49-F238E27FC236}">
-                <a16:creationId xmlns:a16="http://schemas.microsoft.com/office/drawing/2014/main" id="{A4BD182C-3E32-4287-A1CA-8531FB51E996}"/>
+                <a16:creationId xmlns:a16="http://schemas.microsoft.com/office/drawing/2014/main" id="{29939A14-B880-4195-9646-0F79DC8568C7}"/>
               </a:ext>
             </a:extLst>
           </p:cNvPr>
@@ -2098,7 +2098,7 @@
           <p:cNvPr id="12" name="founder-line">
             <a:extLst xmlns:a="http://schemas.openxmlformats.org/drawingml/2006/main">
               <a:ext uri="{FF2B5EF4-FFF2-40B4-BE49-F238E27FC236}">
-                <a16:creationId xmlns:a16="http://schemas.microsoft.com/office/drawing/2014/main" id="{CBD624FB-9F56-4B41-BF5C-4A4CED50F0AE}"/>
+                <a16:creationId xmlns:a16="http://schemas.microsoft.com/office/drawing/2014/main" id="{4C8661A1-BD22-4476-A907-D4C491F15864}"/>
               </a:ext>
             </a:extLst>
           </p:cNvPr>
@@ -2154,7 +2154,7 @@
     </p:spTree>
     <p:extLst>
       <p:ext uri="{BB962C8B-B14F-4D97-AF65-F5344CB8AC3E}">
-        <p14:creationId xmlns:p14="http://schemas.microsoft.com/office/powerpoint/2010/main" val="1321911565"/>
+        <p14:creationId xmlns:p14="http://schemas.microsoft.com/office/powerpoint/2010/main" val="716092757"/>
       </p:ext>
     </p:extLst>
   </p:cSld>
@@ -2185,7 +2185,7 @@
           <p:cNvPr id="15" name="brand-2">
             <a:extLst xmlns:a="http://schemas.openxmlformats.org/drawingml/2006/main">
               <a:ext uri="{FF2B5EF4-FFF2-40B4-BE49-F238E27FC236}">
-                <a16:creationId xmlns:a16="http://schemas.microsoft.com/office/drawing/2014/main" id="{4663A763-4504-4F9E-9929-7C1473E50ED2}"/>
+                <a16:creationId xmlns:a16="http://schemas.microsoft.com/office/drawing/2014/main" id="{D7051D99-7F00-40E3-B429-AE32369C97B0}"/>
               </a:ext>
             </a:extLst>
           </p:cNvPr>
@@ -2243,7 +2243,7 @@
           <p:cNvPr id="2" name="round-2">
             <a:extLst xmlns:a="http://schemas.openxmlformats.org/drawingml/2006/main">
               <a:ext uri="{FF2B5EF4-FFF2-40B4-BE49-F238E27FC236}">
-                <a16:creationId xmlns:a16="http://schemas.microsoft.com/office/drawing/2014/main" id="{E3A08B5C-67C4-47B9-9B81-CCF7EE96A7F5}"/>
+                <a16:creationId xmlns:a16="http://schemas.microsoft.com/office/drawing/2014/main" id="{BE011543-B5AB-45AA-B844-F875940BF3A5}"/>
               </a:ext>
             </a:extLst>
           </p:cNvPr>
@@ -2301,7 +2301,7 @@
           <p:cNvPr id="3" name="top-rule-2">
             <a:extLst xmlns:a="http://schemas.openxmlformats.org/drawingml/2006/main">
               <a:ext uri="{FF2B5EF4-FFF2-40B4-BE49-F238E27FC236}">
-                <a16:creationId xmlns:a16="http://schemas.microsoft.com/office/drawing/2014/main" id="{647DFBDA-BDED-41DB-8AD1-A86A69322C63}"/>
+                <a16:creationId xmlns:a16="http://schemas.microsoft.com/office/drawing/2014/main" id="{396DF957-A8C7-49AC-BAE3-958FDBC5C4E6}"/>
               </a:ext>
             </a:extLst>
           </p:cNvPr>
@@ -2334,7 +2334,7 @@
           <p:cNvPr id="4" name="left-grid-2">
             <a:extLst xmlns:a="http://schemas.openxmlformats.org/drawingml/2006/main">
               <a:ext uri="{FF2B5EF4-FFF2-40B4-BE49-F238E27FC236}">
-                <a16:creationId xmlns:a16="http://schemas.microsoft.com/office/drawing/2014/main" id="{31E58AF8-EC1F-45B7-83DE-825AE4CCDB52}"/>
+                <a16:creationId xmlns:a16="http://schemas.microsoft.com/office/drawing/2014/main" id="{8D51CE1C-3BF4-46F9-A35E-65FE60844823}"/>
               </a:ext>
             </a:extLst>
           </p:cNvPr>
@@ -2367,7 +2367,7 @@
           <p:cNvPr id="5" name="center-grid-2">
             <a:extLst xmlns:a="http://schemas.openxmlformats.org/drawingml/2006/main">
               <a:ext uri="{FF2B5EF4-FFF2-40B4-BE49-F238E27FC236}">
-                <a16:creationId xmlns:a16="http://schemas.microsoft.com/office/drawing/2014/main" id="{30EF0D8E-4381-49AC-B81D-7617D3071E58}"/>
+                <a16:creationId xmlns:a16="http://schemas.microsoft.com/office/drawing/2014/main" id="{F3A88BBC-ECA8-430A-AAC3-873FA03A4391}"/>
               </a:ext>
             </a:extLst>
           </p:cNvPr>
@@ -2400,7 +2400,7 @@
           <p:cNvPr id="6" name="right-grid-2">
             <a:extLst xmlns:a="http://schemas.openxmlformats.org/drawingml/2006/main">
               <a:ext uri="{FF2B5EF4-FFF2-40B4-BE49-F238E27FC236}">
-                <a16:creationId xmlns:a16="http://schemas.microsoft.com/office/drawing/2014/main" id="{BACDD5D9-834C-426E-BF03-F94955C061ED}"/>
+                <a16:creationId xmlns:a16="http://schemas.microsoft.com/office/drawing/2014/main" id="{E013166A-97C0-458D-801F-51362263C086}"/>
               </a:ext>
             </a:extLst>
           </p:cNvPr>
@@ -2433,7 +2433,7 @@
           <p:cNvPr id="7" name="bottom-rule-2">
             <a:extLst xmlns:a="http://schemas.openxmlformats.org/drawingml/2006/main">
               <a:ext uri="{FF2B5EF4-FFF2-40B4-BE49-F238E27FC236}">
-                <a16:creationId xmlns:a16="http://schemas.microsoft.com/office/drawing/2014/main" id="{9D999CF5-46EC-4A58-BFEB-6E635FA229F2}"/>
+                <a16:creationId xmlns:a16="http://schemas.microsoft.com/office/drawing/2014/main" id="{FD468988-D43A-4DA5-848C-68C40B451AD8}"/>
               </a:ext>
             </a:extLst>
           </p:cNvPr>
@@ -2466,7 +2466,7 @@
           <p:cNvPr id="8" name="page-2">
             <a:extLst xmlns:a="http://schemas.openxmlformats.org/drawingml/2006/main">
               <a:ext uri="{FF2B5EF4-FFF2-40B4-BE49-F238E27FC236}">
-                <a16:creationId xmlns:a16="http://schemas.microsoft.com/office/drawing/2014/main" id="{056F92D4-4551-4CE8-AB6E-332722C70351}"/>
+                <a16:creationId xmlns:a16="http://schemas.microsoft.com/office/drawing/2014/main" id="{AD8098AA-5BFF-4CFF-BADE-8E8EAB2EF332}"/>
               </a:ext>
             </a:extLst>
           </p:cNvPr>
@@ -2524,7 +2524,7 @@
           <p:cNvPr id="9" name="problem-title">
             <a:extLst xmlns:a="http://schemas.openxmlformats.org/drawingml/2006/main">
               <a:ext uri="{FF2B5EF4-FFF2-40B4-BE49-F238E27FC236}">
-                <a16:creationId xmlns:a16="http://schemas.microsoft.com/office/drawing/2014/main" id="{F34B716E-A889-4563-80EF-BE125266D244}"/>
+                <a16:creationId xmlns:a16="http://schemas.microsoft.com/office/drawing/2014/main" id="{390833B5-6799-4CB3-BD3F-4801ADE1A9CF}"/>
               </a:ext>
             </a:extLst>
           </p:cNvPr>
@@ -2605,7 +2605,7 @@
           <p:cNvPr id="10" name="problem-copy">
             <a:extLst xmlns:a="http://schemas.openxmlformats.org/drawingml/2006/main">
               <a:ext uri="{FF2B5EF4-FFF2-40B4-BE49-F238E27FC236}">
-                <a16:creationId xmlns:a16="http://schemas.microsoft.com/office/drawing/2014/main" id="{94A5D0CA-7353-477F-9DC5-752B53AABA54}"/>
+                <a16:creationId xmlns:a16="http://schemas.microsoft.com/office/drawing/2014/main" id="{C93228B2-61C2-4642-A861-4D67789C6968}"/>
               </a:ext>
             </a:extLst>
           </p:cNvPr>
@@ -2686,7 +2686,7 @@
           <p:cNvPr id="11" name="problem-accent">
             <a:extLst xmlns:a="http://schemas.openxmlformats.org/drawingml/2006/main">
               <a:ext uri="{FF2B5EF4-FFF2-40B4-BE49-F238E27FC236}">
-                <a16:creationId xmlns:a16="http://schemas.microsoft.com/office/drawing/2014/main" id="{8D28411E-D1E6-4006-9BF6-BFFFB8D3B073}"/>
+                <a16:creationId xmlns:a16="http://schemas.microsoft.com/office/drawing/2014/main" id="{6DD737C0-34FA-4C70-B21E-3B58E969BB11}"/>
               </a:ext>
             </a:extLst>
           </p:cNvPr>
@@ -2719,7 +2719,7 @@
           <p:cNvPr id="12" name="problem-outcome">
             <a:extLst xmlns:a="http://schemas.openxmlformats.org/drawingml/2006/main">
               <a:ext uri="{FF2B5EF4-FFF2-40B4-BE49-F238E27FC236}">
-                <a16:creationId xmlns:a16="http://schemas.microsoft.com/office/drawing/2014/main" id="{9388B53D-ED7D-41BE-B516-5326251E1C03}"/>
+                <a16:creationId xmlns:a16="http://schemas.microsoft.com/office/drawing/2014/main" id="{B982973F-769C-4B15-99A5-B9F852FE763C}"/>
               </a:ext>
             </a:extLst>
           </p:cNvPr>
@@ -2804,7 +2804,7 @@
           <p:nvPr/>
         </p:nvPicPr>
         <p:blipFill>
-          <a:blip xmlns:r="http://schemas.openxmlformats.org/officeDocument/2006/relationships" xmlns:a="http://schemas.openxmlformats.org/drawingml/2006/main" r:embed="R9b437ecc1c714646"/>
+          <a:blip xmlns:r="http://schemas.openxmlformats.org/officeDocument/2006/relationships" xmlns:a="http://schemas.openxmlformats.org/drawingml/2006/main" r:embed="R6ba02264515b4c6d"/>
           <a:srcRect xmlns:a="http://schemas.openxmlformats.org/drawingml/2006/main" l="22485" t="0" r="22485" b="0"/>
           <a:stretch xmlns:a="http://schemas.openxmlformats.org/drawingml/2006/main">
             <a:fillRect l="0" t="0" r="0" b="0"/>
@@ -2825,7 +2825,7 @@
           <p:cNvPr id="14" name="story-frame">
             <a:extLst xmlns:a="http://schemas.openxmlformats.org/drawingml/2006/main">
               <a:ext uri="{FF2B5EF4-FFF2-40B4-BE49-F238E27FC236}">
-                <a16:creationId xmlns:a16="http://schemas.microsoft.com/office/drawing/2014/main" id="{C09BA845-7F84-4E8B-8840-8795ED1B95DA}"/>
+                <a16:creationId xmlns:a16="http://schemas.microsoft.com/office/drawing/2014/main" id="{FA2D41BF-17D5-4EC2-9BC8-A7C48E1D4C1E}"/>
               </a:ext>
             </a:extLst>
           </p:cNvPr>
@@ -2854,7 +2854,7 @@
     </p:spTree>
     <p:extLst>
       <p:ext uri="{BB962C8B-B14F-4D97-AF65-F5344CB8AC3E}">
-        <p14:creationId xmlns:p14="http://schemas.microsoft.com/office/powerpoint/2010/main" val="1458514047"/>
+        <p14:creationId xmlns:p14="http://schemas.microsoft.com/office/powerpoint/2010/main" val="1878297837"/>
       </p:ext>
     </p:extLst>
   </p:cSld>
@@ -2885,7 +2885,7 @@
           <p:cNvPr id="16" name="brand-3">
             <a:extLst xmlns:a="http://schemas.openxmlformats.org/drawingml/2006/main">
               <a:ext uri="{FF2B5EF4-FFF2-40B4-BE49-F238E27FC236}">
-                <a16:creationId xmlns:a16="http://schemas.microsoft.com/office/drawing/2014/main" id="{4F9199D4-B81E-4BE7-A72C-A9F0412505CF}"/>
+                <a16:creationId xmlns:a16="http://schemas.microsoft.com/office/drawing/2014/main" id="{BCE8AA36-B5E0-4761-AD18-3A736768387A}"/>
               </a:ext>
             </a:extLst>
           </p:cNvPr>
@@ -2943,7 +2943,7 @@
           <p:cNvPr id="2" name="round-3">
             <a:extLst xmlns:a="http://schemas.openxmlformats.org/drawingml/2006/main">
               <a:ext uri="{FF2B5EF4-FFF2-40B4-BE49-F238E27FC236}">
-                <a16:creationId xmlns:a16="http://schemas.microsoft.com/office/drawing/2014/main" id="{412F7756-F298-486E-A8F4-94C73A09FBFB}"/>
+                <a16:creationId xmlns:a16="http://schemas.microsoft.com/office/drawing/2014/main" id="{E7FCCF19-3BBC-4053-99D0-86AC26755412}"/>
               </a:ext>
             </a:extLst>
           </p:cNvPr>
@@ -3001,7 +3001,7 @@
           <p:cNvPr id="3" name="top-rule-3">
             <a:extLst xmlns:a="http://schemas.openxmlformats.org/drawingml/2006/main">
               <a:ext uri="{FF2B5EF4-FFF2-40B4-BE49-F238E27FC236}">
-                <a16:creationId xmlns:a16="http://schemas.microsoft.com/office/drawing/2014/main" id="{BF3724C7-6876-4190-A7E5-479EAED85CA5}"/>
+                <a16:creationId xmlns:a16="http://schemas.microsoft.com/office/drawing/2014/main" id="{4624381B-2059-4CD7-9344-CA0DB3C8ED8B}"/>
               </a:ext>
             </a:extLst>
           </p:cNvPr>
@@ -3034,7 +3034,7 @@
           <p:cNvPr id="4" name="left-grid-3">
             <a:extLst xmlns:a="http://schemas.openxmlformats.org/drawingml/2006/main">
               <a:ext uri="{FF2B5EF4-FFF2-40B4-BE49-F238E27FC236}">
-                <a16:creationId xmlns:a16="http://schemas.microsoft.com/office/drawing/2014/main" id="{9037205F-88C6-421E-B04E-31C8BE2CA079}"/>
+                <a16:creationId xmlns:a16="http://schemas.microsoft.com/office/drawing/2014/main" id="{11D7EE24-2E41-49DC-8821-C7FC5B1F7AD6}"/>
               </a:ext>
             </a:extLst>
           </p:cNvPr>
@@ -3067,7 +3067,7 @@
           <p:cNvPr id="5" name="center-grid-3">
             <a:extLst xmlns:a="http://schemas.openxmlformats.org/drawingml/2006/main">
               <a:ext uri="{FF2B5EF4-FFF2-40B4-BE49-F238E27FC236}">
-                <a16:creationId xmlns:a16="http://schemas.microsoft.com/office/drawing/2014/main" id="{9D9B11AB-FDAF-4DA5-9826-D9DFD053C36B}"/>
+                <a16:creationId xmlns:a16="http://schemas.microsoft.com/office/drawing/2014/main" id="{DA3B6609-3E62-47F4-911A-5EE8663BB7A4}"/>
               </a:ext>
             </a:extLst>
           </p:cNvPr>
@@ -3100,7 +3100,7 @@
           <p:cNvPr id="6" name="right-grid-3">
             <a:extLst xmlns:a="http://schemas.openxmlformats.org/drawingml/2006/main">
               <a:ext uri="{FF2B5EF4-FFF2-40B4-BE49-F238E27FC236}">
-                <a16:creationId xmlns:a16="http://schemas.microsoft.com/office/drawing/2014/main" id="{C955ACA0-0151-4074-A9DB-30DBEDBB6166}"/>
+                <a16:creationId xmlns:a16="http://schemas.microsoft.com/office/drawing/2014/main" id="{DB8383FF-1369-401B-98ED-D4CDFFDA0633}"/>
               </a:ext>
             </a:extLst>
           </p:cNvPr>
@@ -3133,7 +3133,7 @@
           <p:cNvPr id="7" name="bottom-rule-3">
             <a:extLst xmlns:a="http://schemas.openxmlformats.org/drawingml/2006/main">
               <a:ext uri="{FF2B5EF4-FFF2-40B4-BE49-F238E27FC236}">
-                <a16:creationId xmlns:a16="http://schemas.microsoft.com/office/drawing/2014/main" id="{BF56DFAC-136C-4321-B713-6142C6C57969}"/>
+                <a16:creationId xmlns:a16="http://schemas.microsoft.com/office/drawing/2014/main" id="{B2E3F309-0E44-499C-9C14-73E7BCBF2215}"/>
               </a:ext>
             </a:extLst>
           </p:cNvPr>
@@ -3166,7 +3166,7 @@
           <p:cNvPr id="8" name="page-3">
             <a:extLst xmlns:a="http://schemas.openxmlformats.org/drawingml/2006/main">
               <a:ext uri="{FF2B5EF4-FFF2-40B4-BE49-F238E27FC236}">
-                <a16:creationId xmlns:a16="http://schemas.microsoft.com/office/drawing/2014/main" id="{5C1493D6-F4CE-4D24-8D47-B4213D65EF6D}"/>
+                <a16:creationId xmlns:a16="http://schemas.microsoft.com/office/drawing/2014/main" id="{8BA90A62-2127-45E6-BADA-F202A7D68752}"/>
               </a:ext>
             </a:extLst>
           </p:cNvPr>
@@ -3224,7 +3224,7 @@
           <p:cNvPr id="9" name="input-kicker">
             <a:extLst xmlns:a="http://schemas.openxmlformats.org/drawingml/2006/main">
               <a:ext uri="{FF2B5EF4-FFF2-40B4-BE49-F238E27FC236}">
-                <a16:creationId xmlns:a16="http://schemas.microsoft.com/office/drawing/2014/main" id="{C2AC9930-A440-405E-B2A7-C466AC1BC628}"/>
+                <a16:creationId xmlns:a16="http://schemas.microsoft.com/office/drawing/2014/main" id="{EB2C92A2-A34D-4E1F-B93B-E977A8AEDE9D}"/>
               </a:ext>
             </a:extLst>
           </p:cNvPr>
@@ -3282,7 +3282,7 @@
           <p:cNvPr id="10" name="input-title">
             <a:extLst xmlns:a="http://schemas.openxmlformats.org/drawingml/2006/main">
               <a:ext uri="{FF2B5EF4-FFF2-40B4-BE49-F238E27FC236}">
-                <a16:creationId xmlns:a16="http://schemas.microsoft.com/office/drawing/2014/main" id="{4FEF8551-D566-40E0-B8B3-6C44EC751592}"/>
+                <a16:creationId xmlns:a16="http://schemas.microsoft.com/office/drawing/2014/main" id="{EE68967E-8C61-4726-AF6D-600F7F3F8465}"/>
               </a:ext>
             </a:extLst>
           </p:cNvPr>
@@ -3363,7 +3363,7 @@
           <p:cNvPr id="11" name="input-copy">
             <a:extLst xmlns:a="http://schemas.openxmlformats.org/drawingml/2006/main">
               <a:ext uri="{FF2B5EF4-FFF2-40B4-BE49-F238E27FC236}">
-                <a16:creationId xmlns:a16="http://schemas.microsoft.com/office/drawing/2014/main" id="{C76A94E8-E000-41C4-9D9E-EAF212DB70BC}"/>
+                <a16:creationId xmlns:a16="http://schemas.microsoft.com/office/drawing/2014/main" id="{038B2A36-BFC3-499F-A689-FDFB500A904F}"/>
               </a:ext>
             </a:extLst>
           </p:cNvPr>
@@ -3444,7 +3444,7 @@
           <p:cNvPr id="12" name="input-accent">
             <a:extLst xmlns:a="http://schemas.openxmlformats.org/drawingml/2006/main">
               <a:ext uri="{FF2B5EF4-FFF2-40B4-BE49-F238E27FC236}">
-                <a16:creationId xmlns:a16="http://schemas.microsoft.com/office/drawing/2014/main" id="{EC663A88-381D-441B-8A3A-33217D6FF384}"/>
+                <a16:creationId xmlns:a16="http://schemas.microsoft.com/office/drawing/2014/main" id="{03C018AA-EE3A-4CB6-BE58-3272F5AB67AF}"/>
               </a:ext>
             </a:extLst>
           </p:cNvPr>
@@ -3477,7 +3477,7 @@
           <p:cNvPr id="13" name="input-boundary">
             <a:extLst xmlns:a="http://schemas.openxmlformats.org/drawingml/2006/main">
               <a:ext uri="{FF2B5EF4-FFF2-40B4-BE49-F238E27FC236}">
-                <a16:creationId xmlns:a16="http://schemas.microsoft.com/office/drawing/2014/main" id="{5EE7FB56-D999-4113-847D-F0D36A26F2E5}"/>
+                <a16:creationId xmlns:a16="http://schemas.microsoft.com/office/drawing/2014/main" id="{B27A89B7-5FD1-4A45-ADD9-E78B3C1D8782}"/>
               </a:ext>
             </a:extLst>
           </p:cNvPr>
@@ -3558,7 +3558,7 @@
           <p:cNvPr id="14" name="input-screen-backing">
             <a:extLst xmlns:a="http://schemas.openxmlformats.org/drawingml/2006/main">
               <a:ext uri="{FF2B5EF4-FFF2-40B4-BE49-F238E27FC236}">
-                <a16:creationId xmlns:a16="http://schemas.microsoft.com/office/drawing/2014/main" id="{C6AD5613-90D1-4159-934B-CDC52CFDD8EE}"/>
+                <a16:creationId xmlns:a16="http://schemas.microsoft.com/office/drawing/2014/main" id="{49A772E4-9C0D-4AE1-9B9D-6E49E40C1E4D}"/>
               </a:ext>
             </a:extLst>
           </p:cNvPr>
@@ -3595,7 +3595,7 @@
           <p:nvPr/>
         </p:nvPicPr>
         <p:blipFill>
-          <a:blip xmlns:r="http://schemas.openxmlformats.org/officeDocument/2006/relationships" xmlns:a="http://schemas.openxmlformats.org/drawingml/2006/main" r:embed="Ra1ddc93f92934b5c"/>
+          <a:blip xmlns:r="http://schemas.openxmlformats.org/officeDocument/2006/relationships" xmlns:a="http://schemas.openxmlformats.org/drawingml/2006/main" r:embed="R6e0667d62d204405"/>
           <a:srcRect xmlns:a="http://schemas.openxmlformats.org/drawingml/2006/main" l="0" t="2543" r="0" b="2543"/>
           <a:stretch xmlns:a="http://schemas.openxmlformats.org/drawingml/2006/main">
             <a:fillRect l="0" t="0" r="0" b="0"/>
@@ -3614,7 +3614,7 @@
     </p:spTree>
     <p:extLst>
       <p:ext uri="{BB962C8B-B14F-4D97-AF65-F5344CB8AC3E}">
-        <p14:creationId xmlns:p14="http://schemas.microsoft.com/office/powerpoint/2010/main" val="968657474"/>
+        <p14:creationId xmlns:p14="http://schemas.microsoft.com/office/powerpoint/2010/main" val="661324228"/>
       </p:ext>
     </p:extLst>
   </p:cSld>
@@ -3645,7 +3645,7 @@
           <p:cNvPr id="16" name="brand-4">
             <a:extLst xmlns:a="http://schemas.openxmlformats.org/drawingml/2006/main">
               <a:ext uri="{FF2B5EF4-FFF2-40B4-BE49-F238E27FC236}">
-                <a16:creationId xmlns:a16="http://schemas.microsoft.com/office/drawing/2014/main" id="{8612D0E9-4969-4FAA-AF75-D78E04E6C86A}"/>
+                <a16:creationId xmlns:a16="http://schemas.microsoft.com/office/drawing/2014/main" id="{B9FFC7BC-AB3F-481D-B216-91716F0D1965}"/>
               </a:ext>
             </a:extLst>
           </p:cNvPr>
@@ -3703,7 +3703,7 @@
           <p:cNvPr id="2" name="round-4">
             <a:extLst xmlns:a="http://schemas.openxmlformats.org/drawingml/2006/main">
               <a:ext uri="{FF2B5EF4-FFF2-40B4-BE49-F238E27FC236}">
-                <a16:creationId xmlns:a16="http://schemas.microsoft.com/office/drawing/2014/main" id="{C73161E0-A1F8-4259-AACC-6717E8459C9D}"/>
+                <a16:creationId xmlns:a16="http://schemas.microsoft.com/office/drawing/2014/main" id="{ACF6D306-EA22-465B-9E7C-9CBFD5BB6201}"/>
               </a:ext>
             </a:extLst>
           </p:cNvPr>
@@ -3761,7 +3761,7 @@
           <p:cNvPr id="3" name="top-rule-4">
             <a:extLst xmlns:a="http://schemas.openxmlformats.org/drawingml/2006/main">
               <a:ext uri="{FF2B5EF4-FFF2-40B4-BE49-F238E27FC236}">
-                <a16:creationId xmlns:a16="http://schemas.microsoft.com/office/drawing/2014/main" id="{977BDCE8-FB40-477A-9750-BFCCB91F86EB}"/>
+                <a16:creationId xmlns:a16="http://schemas.microsoft.com/office/drawing/2014/main" id="{5B7AE2B1-5F8B-4C2A-ABF2-4C294561558B}"/>
               </a:ext>
             </a:extLst>
           </p:cNvPr>
@@ -3794,7 +3794,7 @@
           <p:cNvPr id="4" name="left-grid-4">
             <a:extLst xmlns:a="http://schemas.openxmlformats.org/drawingml/2006/main">
               <a:ext uri="{FF2B5EF4-FFF2-40B4-BE49-F238E27FC236}">
-                <a16:creationId xmlns:a16="http://schemas.microsoft.com/office/drawing/2014/main" id="{4AA43960-F563-41B5-B092-AB7007DC3831}"/>
+                <a16:creationId xmlns:a16="http://schemas.microsoft.com/office/drawing/2014/main" id="{17A3BBDC-0D56-47F1-BA81-8CE51615114D}"/>
               </a:ext>
             </a:extLst>
           </p:cNvPr>
@@ -3827,7 +3827,7 @@
           <p:cNvPr id="5" name="center-grid-4">
             <a:extLst xmlns:a="http://schemas.openxmlformats.org/drawingml/2006/main">
               <a:ext uri="{FF2B5EF4-FFF2-40B4-BE49-F238E27FC236}">
-                <a16:creationId xmlns:a16="http://schemas.microsoft.com/office/drawing/2014/main" id="{20C40BC2-902D-4629-B095-F015913269C8}"/>
+                <a16:creationId xmlns:a16="http://schemas.microsoft.com/office/drawing/2014/main" id="{91BB188E-E349-40AF-BD60-8C1E6566CC6F}"/>
               </a:ext>
             </a:extLst>
           </p:cNvPr>
@@ -3860,7 +3860,7 @@
           <p:cNvPr id="6" name="right-grid-4">
             <a:extLst xmlns:a="http://schemas.openxmlformats.org/drawingml/2006/main">
               <a:ext uri="{FF2B5EF4-FFF2-40B4-BE49-F238E27FC236}">
-                <a16:creationId xmlns:a16="http://schemas.microsoft.com/office/drawing/2014/main" id="{596CDD7E-3209-44E8-847F-B9756D047770}"/>
+                <a16:creationId xmlns:a16="http://schemas.microsoft.com/office/drawing/2014/main" id="{BD328320-0D67-4617-80F3-1DA42E41F8A9}"/>
               </a:ext>
             </a:extLst>
           </p:cNvPr>
@@ -3893,7 +3893,7 @@
           <p:cNvPr id="7" name="bottom-rule-4">
             <a:extLst xmlns:a="http://schemas.openxmlformats.org/drawingml/2006/main">
               <a:ext uri="{FF2B5EF4-FFF2-40B4-BE49-F238E27FC236}">
-                <a16:creationId xmlns:a16="http://schemas.microsoft.com/office/drawing/2014/main" id="{EE8ED25E-25F5-4D27-A881-D33E8E16DDA7}"/>
+                <a16:creationId xmlns:a16="http://schemas.microsoft.com/office/drawing/2014/main" id="{0BFB3843-7388-473E-A2AE-6AB1892167AC}"/>
               </a:ext>
             </a:extLst>
           </p:cNvPr>
@@ -3926,7 +3926,7 @@
           <p:cNvPr id="8" name="page-4">
             <a:extLst xmlns:a="http://schemas.openxmlformats.org/drawingml/2006/main">
               <a:ext uri="{FF2B5EF4-FFF2-40B4-BE49-F238E27FC236}">
-                <a16:creationId xmlns:a16="http://schemas.microsoft.com/office/drawing/2014/main" id="{E73E8F96-9347-4238-B898-4FD1274AD96B}"/>
+                <a16:creationId xmlns:a16="http://schemas.microsoft.com/office/drawing/2014/main" id="{47080BD6-AE6A-46D0-81A3-3C63679CF237}"/>
               </a:ext>
             </a:extLst>
           </p:cNvPr>
@@ -3984,7 +3984,7 @@
           <p:cNvPr id="9" name="output-kicker">
             <a:extLst xmlns:a="http://schemas.openxmlformats.org/drawingml/2006/main">
               <a:ext uri="{FF2B5EF4-FFF2-40B4-BE49-F238E27FC236}">
-                <a16:creationId xmlns:a16="http://schemas.microsoft.com/office/drawing/2014/main" id="{F3561AB0-FCC7-4ABC-92F6-CFB371F9ACB5}"/>
+                <a16:creationId xmlns:a16="http://schemas.microsoft.com/office/drawing/2014/main" id="{0A8259BC-A857-47A9-9189-41DAC05903FB}"/>
               </a:ext>
             </a:extLst>
           </p:cNvPr>
@@ -4042,7 +4042,7 @@
           <p:cNvPr id="10" name="output-title">
             <a:extLst xmlns:a="http://schemas.openxmlformats.org/drawingml/2006/main">
               <a:ext uri="{FF2B5EF4-FFF2-40B4-BE49-F238E27FC236}">
-                <a16:creationId xmlns:a16="http://schemas.microsoft.com/office/drawing/2014/main" id="{909FF9AF-E9F6-4FD5-BBFE-3C7DD203AF8E}"/>
+                <a16:creationId xmlns:a16="http://schemas.microsoft.com/office/drawing/2014/main" id="{F47525EA-91F7-4D2A-8766-B9776FB0164F}"/>
               </a:ext>
             </a:extLst>
           </p:cNvPr>
@@ -4123,7 +4123,7 @@
           <p:cNvPr id="11" name="output-action">
             <a:extLst xmlns:a="http://schemas.openxmlformats.org/drawingml/2006/main">
               <a:ext uri="{FF2B5EF4-FFF2-40B4-BE49-F238E27FC236}">
-                <a16:creationId xmlns:a16="http://schemas.microsoft.com/office/drawing/2014/main" id="{88D9AD4B-7679-45ED-9DA7-50CB71D9D5DD}"/>
+                <a16:creationId xmlns:a16="http://schemas.microsoft.com/office/drawing/2014/main" id="{D53125D5-C4E5-4D0C-90D7-98A55A1F9DCF}"/>
               </a:ext>
             </a:extLst>
           </p:cNvPr>
@@ -4204,7 +4204,7 @@
           <p:cNvPr id="12" name="output-accent">
             <a:extLst xmlns:a="http://schemas.openxmlformats.org/drawingml/2006/main">
               <a:ext uri="{FF2B5EF4-FFF2-40B4-BE49-F238E27FC236}">
-                <a16:creationId xmlns:a16="http://schemas.microsoft.com/office/drawing/2014/main" id="{54AB8F6B-C5D6-402D-B2BA-5D48779C4A00}"/>
+                <a16:creationId xmlns:a16="http://schemas.microsoft.com/office/drawing/2014/main" id="{145FDA0B-C439-479F-A01C-7A70B8F36250}"/>
               </a:ext>
             </a:extLst>
           </p:cNvPr>
@@ -4237,7 +4237,7 @@
           <p:cNvPr id="13" name="output-control">
             <a:extLst xmlns:a="http://schemas.openxmlformats.org/drawingml/2006/main">
               <a:ext uri="{FF2B5EF4-FFF2-40B4-BE49-F238E27FC236}">
-                <a16:creationId xmlns:a16="http://schemas.microsoft.com/office/drawing/2014/main" id="{D4B2D229-E97A-476C-ACE4-03BEE6937FEA}"/>
+                <a16:creationId xmlns:a16="http://schemas.microsoft.com/office/drawing/2014/main" id="{18A7CBAC-C298-43F6-B690-42151F0E7734}"/>
               </a:ext>
             </a:extLst>
           </p:cNvPr>
@@ -4318,7 +4318,7 @@
           <p:cNvPr id="14" name="recommendation-screen-backing">
             <a:extLst xmlns:a="http://schemas.openxmlformats.org/drawingml/2006/main">
               <a:ext uri="{FF2B5EF4-FFF2-40B4-BE49-F238E27FC236}">
-                <a16:creationId xmlns:a16="http://schemas.microsoft.com/office/drawing/2014/main" id="{3B5C60CF-4AE9-4ED8-B128-B60878B35093}"/>
+                <a16:creationId xmlns:a16="http://schemas.microsoft.com/office/drawing/2014/main" id="{D3428881-CADB-49AA-97E9-63FF0CEBAC7B}"/>
               </a:ext>
             </a:extLst>
           </p:cNvPr>
@@ -4355,7 +4355,7 @@
           <p:nvPr/>
         </p:nvPicPr>
         <p:blipFill>
-          <a:blip xmlns:r="http://schemas.openxmlformats.org/officeDocument/2006/relationships" xmlns:a="http://schemas.openxmlformats.org/drawingml/2006/main" r:embed="Rd89f00eb74ce4acc"/>
+          <a:blip xmlns:r="http://schemas.openxmlformats.org/officeDocument/2006/relationships" xmlns:a="http://schemas.openxmlformats.org/drawingml/2006/main" r:embed="R2b758c3adb914738"/>
           <a:srcRect xmlns:a="http://schemas.openxmlformats.org/drawingml/2006/main" l="0" t="5805" r="0" b="5805"/>
           <a:stretch xmlns:a="http://schemas.openxmlformats.org/drawingml/2006/main">
             <a:fillRect l="0" t="0" r="0" b="0"/>
@@ -4374,7 +4374,7 @@
     </p:spTree>
     <p:extLst>
       <p:ext uri="{BB962C8B-B14F-4D97-AF65-F5344CB8AC3E}">
-        <p14:creationId xmlns:p14="http://schemas.microsoft.com/office/powerpoint/2010/main" val="1379427706"/>
+        <p14:creationId xmlns:p14="http://schemas.microsoft.com/office/powerpoint/2010/main" val="1081888785"/>
       </p:ext>
     </p:extLst>
   </p:cSld>
@@ -4405,7 +4405,7 @@
           <p:cNvPr id="18" name="brand-5">
             <a:extLst xmlns:a="http://schemas.openxmlformats.org/drawingml/2006/main">
               <a:ext uri="{FF2B5EF4-FFF2-40B4-BE49-F238E27FC236}">
-                <a16:creationId xmlns:a16="http://schemas.microsoft.com/office/drawing/2014/main" id="{1ED663A4-131C-4031-BBDC-0B13A995CA1C}"/>
+                <a16:creationId xmlns:a16="http://schemas.microsoft.com/office/drawing/2014/main" id="{94B60072-7B70-4FB1-BE93-CA26EDEAAC1B}"/>
               </a:ext>
             </a:extLst>
           </p:cNvPr>
@@ -4463,7 +4463,7 @@
           <p:cNvPr id="2" name="round-5">
             <a:extLst xmlns:a="http://schemas.openxmlformats.org/drawingml/2006/main">
               <a:ext uri="{FF2B5EF4-FFF2-40B4-BE49-F238E27FC236}">
-                <a16:creationId xmlns:a16="http://schemas.microsoft.com/office/drawing/2014/main" id="{B1737D15-4004-4A53-A6E7-F61D9AB09901}"/>
+                <a16:creationId xmlns:a16="http://schemas.microsoft.com/office/drawing/2014/main" id="{B9183CCC-64DC-4446-B4E9-C94DB3CF66E5}"/>
               </a:ext>
             </a:extLst>
           </p:cNvPr>
@@ -4521,7 +4521,7 @@
           <p:cNvPr id="3" name="top-rule-5">
             <a:extLst xmlns:a="http://schemas.openxmlformats.org/drawingml/2006/main">
               <a:ext uri="{FF2B5EF4-FFF2-40B4-BE49-F238E27FC236}">
-                <a16:creationId xmlns:a16="http://schemas.microsoft.com/office/drawing/2014/main" id="{D5A1E358-35FB-47BB-9B9C-4D6FC3720B4C}"/>
+                <a16:creationId xmlns:a16="http://schemas.microsoft.com/office/drawing/2014/main" id="{76EBB586-50FE-4EEA-97F6-0BF5F44895CD}"/>
               </a:ext>
             </a:extLst>
           </p:cNvPr>
@@ -4554,7 +4554,7 @@
           <p:cNvPr id="4" name="left-grid-5">
             <a:extLst xmlns:a="http://schemas.openxmlformats.org/drawingml/2006/main">
               <a:ext uri="{FF2B5EF4-FFF2-40B4-BE49-F238E27FC236}">
-                <a16:creationId xmlns:a16="http://schemas.microsoft.com/office/drawing/2014/main" id="{A12FB43F-306C-41A3-AAEE-0E80E8A1B45A}"/>
+                <a16:creationId xmlns:a16="http://schemas.microsoft.com/office/drawing/2014/main" id="{0BCC94AE-1A54-46BC-8AF4-BB52CC7B7481}"/>
               </a:ext>
             </a:extLst>
           </p:cNvPr>
@@ -4587,7 +4587,7 @@
           <p:cNvPr id="5" name="center-grid-5">
             <a:extLst xmlns:a="http://schemas.openxmlformats.org/drawingml/2006/main">
               <a:ext uri="{FF2B5EF4-FFF2-40B4-BE49-F238E27FC236}">
-                <a16:creationId xmlns:a16="http://schemas.microsoft.com/office/drawing/2014/main" id="{E82C632F-0EDD-416D-86B7-89F18FFAF4A8}"/>
+                <a16:creationId xmlns:a16="http://schemas.microsoft.com/office/drawing/2014/main" id="{AB7CB0BA-F704-425E-865D-F584D6AD330C}"/>
               </a:ext>
             </a:extLst>
           </p:cNvPr>
@@ -4620,7 +4620,7 @@
           <p:cNvPr id="6" name="right-grid-5">
             <a:extLst xmlns:a="http://schemas.openxmlformats.org/drawingml/2006/main">
               <a:ext uri="{FF2B5EF4-FFF2-40B4-BE49-F238E27FC236}">
-                <a16:creationId xmlns:a16="http://schemas.microsoft.com/office/drawing/2014/main" id="{3F5B6412-7C7B-46AA-A021-0A4F2C00865B}"/>
+                <a16:creationId xmlns:a16="http://schemas.microsoft.com/office/drawing/2014/main" id="{E1D743CF-645A-4466-8BA9-AA8536C1C79E}"/>
               </a:ext>
             </a:extLst>
           </p:cNvPr>
@@ -4653,7 +4653,7 @@
           <p:cNvPr id="7" name="bottom-rule-5">
             <a:extLst xmlns:a="http://schemas.openxmlformats.org/drawingml/2006/main">
               <a:ext uri="{FF2B5EF4-FFF2-40B4-BE49-F238E27FC236}">
-                <a16:creationId xmlns:a16="http://schemas.microsoft.com/office/drawing/2014/main" id="{4D4CD95C-B46C-4979-85AD-E728E7C0CBEE}"/>
+                <a16:creationId xmlns:a16="http://schemas.microsoft.com/office/drawing/2014/main" id="{007CE19B-D928-4E14-8DDC-F3A19196615B}"/>
               </a:ext>
             </a:extLst>
           </p:cNvPr>
@@ -4686,7 +4686,7 @@
           <p:cNvPr id="8" name="page-5">
             <a:extLst xmlns:a="http://schemas.openxmlformats.org/drawingml/2006/main">
               <a:ext uri="{FF2B5EF4-FFF2-40B4-BE49-F238E27FC236}">
-                <a16:creationId xmlns:a16="http://schemas.microsoft.com/office/drawing/2014/main" id="{AB679F85-A64C-4BD3-A5C0-E84DB7153D32}"/>
+                <a16:creationId xmlns:a16="http://schemas.microsoft.com/office/drawing/2014/main" id="{7009B9A1-4B0F-406E-91DC-5DB533FB6F52}"/>
               </a:ext>
             </a:extLst>
           </p:cNvPr>
@@ -4744,7 +4744,7 @@
           <p:cNvPr id="9" name="close-kicker">
             <a:extLst xmlns:a="http://schemas.openxmlformats.org/drawingml/2006/main">
               <a:ext uri="{FF2B5EF4-FFF2-40B4-BE49-F238E27FC236}">
-                <a16:creationId xmlns:a16="http://schemas.microsoft.com/office/drawing/2014/main" id="{C352D0B1-4C89-4C2D-8468-7DE5E16BCC05}"/>
+                <a16:creationId xmlns:a16="http://schemas.microsoft.com/office/drawing/2014/main" id="{B41EE699-767F-47CD-8965-59CA113E780B}"/>
               </a:ext>
             </a:extLst>
           </p:cNvPr>
@@ -4802,7 +4802,7 @@
           <p:cNvPr id="10" name="close-title">
             <a:extLst xmlns:a="http://schemas.openxmlformats.org/drawingml/2006/main">
               <a:ext uri="{FF2B5EF4-FFF2-40B4-BE49-F238E27FC236}">
-                <a16:creationId xmlns:a16="http://schemas.microsoft.com/office/drawing/2014/main" id="{BB8A3069-A5AF-4877-AE8F-728E91486DE1}"/>
+                <a16:creationId xmlns:a16="http://schemas.microsoft.com/office/drawing/2014/main" id="{8138D656-3C9B-4F85-A390-86953596BFD4}"/>
               </a:ext>
             </a:extLst>
           </p:cNvPr>
@@ -4905,7 +4905,7 @@
           <p:cNvPr id="11" name="close-rule">
             <a:extLst xmlns:a="http://schemas.openxmlformats.org/drawingml/2006/main">
               <a:ext uri="{FF2B5EF4-FFF2-40B4-BE49-F238E27FC236}">
-                <a16:creationId xmlns:a16="http://schemas.microsoft.com/office/drawing/2014/main" id="{502ADBFC-CF74-4BC9-9D88-FBA37F51248F}"/>
+                <a16:creationId xmlns:a16="http://schemas.microsoft.com/office/drawing/2014/main" id="{75AC6DA2-BCC5-4DA4-AE55-823406314C54}"/>
               </a:ext>
             </a:extLst>
           </p:cNvPr>
@@ -4938,7 +4938,7 @@
           <p:cNvPr id="12" name="close-one">
             <a:extLst xmlns:a="http://schemas.openxmlformats.org/drawingml/2006/main">
               <a:ext uri="{FF2B5EF4-FFF2-40B4-BE49-F238E27FC236}">
-                <a16:creationId xmlns:a16="http://schemas.microsoft.com/office/drawing/2014/main" id="{719049D3-B153-4F96-B4A3-27227B87751E}"/>
+                <a16:creationId xmlns:a16="http://schemas.microsoft.com/office/drawing/2014/main" id="{59EEC0C7-A9AC-4F37-9647-8CBC161ACCA6}"/>
               </a:ext>
             </a:extLst>
           </p:cNvPr>
@@ -4996,7 +4996,7 @@
           <p:cNvPr id="13" name="close-one-copy">
             <a:extLst xmlns:a="http://schemas.openxmlformats.org/drawingml/2006/main">
               <a:ext uri="{FF2B5EF4-FFF2-40B4-BE49-F238E27FC236}">
-                <a16:creationId xmlns:a16="http://schemas.microsoft.com/office/drawing/2014/main" id="{7A693DEF-2DDE-43EF-84DB-16B48EAB3C26}"/>
+                <a16:creationId xmlns:a16="http://schemas.microsoft.com/office/drawing/2014/main" id="{D3CEDA7B-DAED-481F-972C-565FEFC48F5B}"/>
               </a:ext>
             </a:extLst>
           </p:cNvPr>
@@ -5054,7 +5054,7 @@
           <p:cNvPr id="14" name="close-two">
             <a:extLst xmlns:a="http://schemas.openxmlformats.org/drawingml/2006/main">
               <a:ext uri="{FF2B5EF4-FFF2-40B4-BE49-F238E27FC236}">
-                <a16:creationId xmlns:a16="http://schemas.microsoft.com/office/drawing/2014/main" id="{86358BC1-8176-49B9-B695-2360775EDCC2}"/>
+                <a16:creationId xmlns:a16="http://schemas.microsoft.com/office/drawing/2014/main" id="{AFC7BBA9-0574-4778-966A-A54EC01B745A}"/>
               </a:ext>
             </a:extLst>
           </p:cNvPr>
@@ -5112,7 +5112,7 @@
           <p:cNvPr id="15" name="close-two-copy">
             <a:extLst xmlns:a="http://schemas.openxmlformats.org/drawingml/2006/main">
               <a:ext uri="{FF2B5EF4-FFF2-40B4-BE49-F238E27FC236}">
-                <a16:creationId xmlns:a16="http://schemas.microsoft.com/office/drawing/2014/main" id="{ADC8CE7E-F06E-49D2-A077-DD623DAB4AEA}"/>
+                <a16:creationId xmlns:a16="http://schemas.microsoft.com/office/drawing/2014/main" id="{39E13A5B-44DC-4E09-B628-B33E09316B30}"/>
               </a:ext>
             </a:extLst>
           </p:cNvPr>
@@ -5170,7 +5170,7 @@
           <p:cNvPr id="16" name="close-three">
             <a:extLst xmlns:a="http://schemas.openxmlformats.org/drawingml/2006/main">
               <a:ext uri="{FF2B5EF4-FFF2-40B4-BE49-F238E27FC236}">
-                <a16:creationId xmlns:a16="http://schemas.microsoft.com/office/drawing/2014/main" id="{D4BEFBB5-B385-4A89-B890-6348455509B2}"/>
+                <a16:creationId xmlns:a16="http://schemas.microsoft.com/office/drawing/2014/main" id="{EEB0B031-7BEB-4EC6-AA2C-5BDA88538F87}"/>
               </a:ext>
             </a:extLst>
           </p:cNvPr>
@@ -5228,7 +5228,7 @@
           <p:cNvPr id="17" name="close-three-copy">
             <a:extLst xmlns:a="http://schemas.openxmlformats.org/drawingml/2006/main">
               <a:ext uri="{FF2B5EF4-FFF2-40B4-BE49-F238E27FC236}">
-                <a16:creationId xmlns:a16="http://schemas.microsoft.com/office/drawing/2014/main" id="{15D1B24C-EBA9-466B-B6C1-C71178CE5811}"/>
+                <a16:creationId xmlns:a16="http://schemas.microsoft.com/office/drawing/2014/main" id="{FC151AAC-61B0-4877-BE83-CEF2C1A3E0C2}"/>
               </a:ext>
             </a:extLst>
           </p:cNvPr>
@@ -5284,7 +5284,7 @@
     </p:spTree>
     <p:extLst>
       <p:ext uri="{BB962C8B-B14F-4D97-AF65-F5344CB8AC3E}">
-        <p14:creationId xmlns:p14="http://schemas.microsoft.com/office/powerpoint/2010/main" val="1096341077"/>
+        <p14:creationId xmlns:p14="http://schemas.microsoft.com/office/powerpoint/2010/main" val="1510774905"/>
       </p:ext>
     </p:extLst>
   </p:cSld>

</xml_diff>